<commit_message>
docs: cap nhat toan bo so do erd use case sequence va tai lieu bao cao do an
</commit_message>
<xml_diff>
--- a/docs/Slide_Thuyet_Trinh_Bao_Ve_PKA_Home.pptx
+++ b/docs/Slide_Thuyet_Trinh_Bao_Ve_PKA_Home.pptx
@@ -24,6 +24,7 @@
     <p:sldId id="272" r:id="rId24"/>
     <p:sldId id="273" r:id="rId25"/>
     <p:sldId id="274" r:id="rId26"/>
+    <p:sldId id="275" r:id="rId27"/>
   </p:sldIdLst>
   <p:sldSz cx="12191695" cy="6858000" type="screen4x3"/>
   <p:notesSz cx="6858000" cy="9144000"/>
@@ -730,7 +731,7 @@
           <a:lstStyle/>
           <a:p>
             <a:r>
-              <a:t>Khi đặt các tiện ích có sức chứa giới hạn như bể bơi hay phòng tập thể thao, hệ thống áp dụng khóa giao dịch để giải quyết bài toán đặt chỗ đồng thời tại cùng một thời điểm, tránh tình trạng vượt quá sức chứa cho phép.</a:t>
+              <a:t>Khi đặt các tiện ích có sức chứa giới hạn như bể bơi hay phòng tập thể thao, hệ thống áp dụng khóa giao dịch để giải quyết bài toán đặt chỗ đồng thời, đồng thời hỗ trợ hủy lịch an toàn tự động hoàn tiền và đôn lượt chờ.</a:t>
             </a:r>
           </a:p>
         </p:txBody>
@@ -800,7 +801,7 @@
           <a:lstStyle/>
           <a:p>
             <a:r>
-              <a:t>Quy trình khai báo chỉ số điện nước kết nối trực tiếp với khâu thanh toán. Kế toán sau khi duyệt ảnh công tơ có thể kích hoạt tạo hóa đơn tự động; cư dân sau đó thanh toán ngay qua cổng VietQR mô phỏng hoặc chuyển khoản hai bước.</a:t>
+              <a:t>Hệ thống bổ sung phân hệ Quản trị tiện ích 3 Tab hiện đại và cơ chế thông báo phân nhóm đích, giúp ban quản lý vận hành chính xác từng dịch vụ tòa nhà mà không làm phiền những cư dân không liên quan.</a:t>
             </a:r>
           </a:p>
         </p:txBody>
@@ -870,7 +871,7 @@
           <a:lstStyle/>
           <a:p>
             <a:r>
-              <a:t>Để bảo đảm phần mềm vận hành ổn định và không phát sinh lỗi tiềm ẩn, em đã xây dựng một bộ test suite gồm 131 tệp với 395 ca kiểm thử tự động. Toàn bộ các ca test đều vượt qua 100%, bảo đảm từ phân tích tĩnh đến kiểm thử bảo mật RLS.</a:t>
+              <a:t>Quy trình khai báo chỉ số điện nước kết nối trực tiếp với khâu thanh toán. Kế toán sau khi duyệt ảnh công tơ có thể kích hoạt tạo hóa đơn tự động; cư dân sau đó thanh toán ngay qua cổng VietQR mô phỏng hoặc chuyển khoản hai bước.</a:t>
             </a:r>
           </a:p>
         </p:txBody>
@@ -940,7 +941,7 @@
           <a:lstStyle/>
           <a:p>
             <a:r>
-              <a:t>Kính mời quý thầy cô quan sát giao diện thực tế của phân hệ Cư dân. Trang chủ được thiết kế theo xu hướng Smart Dashboard với tông màu trực quan, hiển thị công nợ tức thì và hỗ trợ các thao tác thanh toán, báo sự cố chỉ với một chạm.</a:t>
+              <a:t>Để bảo đảm phần mềm vận hành ổn định và không phát sinh lỗi tiềm ẩn, em đã xây dựng một bộ test suite gồm 131 tệp với 408 ca kiểm thử tự động. Toàn bộ các ca test logic đều vượt qua 100%, bảo đảm từ phân tích tĩnh đến kiểm thử bảo mật RLS.</a:t>
             </a:r>
           </a:p>
         </p:txBody>
@@ -1010,7 +1011,7 @@
           <a:lstStyle/>
           <a:p>
             <a:r>
-              <a:t>Đối với phân hệ Ban Quản Lý, bảng điều khiển tập trung toàn bộ các đầu việc tồn đọng dưới dạng thẻ có huy hiệu thông báo số lượng, hỗ trợ lập hóa đơn tự động cho hàng trăm căn hộ và theo dõi điểm đánh giá dịch vụ của từng kỹ thuật viên.</a:t>
+              <a:t>Kính mời quý thầy cô quan sát giao diện thực tế của phân hệ Cư dân. Trang chủ được thiết kế theo xu hướng Smart Dashboard với tông màu trực quan, hiển thị công nợ tức thì và hỗ trợ các thao tác thanh toán, báo sự cố chỉ với một chạm.</a:t>
             </a:r>
           </a:p>
         </p:txBody>
@@ -1080,7 +1081,7 @@
           <a:lstStyle/>
           <a:p>
             <a:r>
-              <a:t>Dự án được triển khai có kỷ luật qua sáu giai đoạn trong vòng sáu tuần, mỗi bước đều có mục tiêu và sản phẩm đầu ra rõ ràng, bảo đảm tiến độ bàn giao đúng hạn.</a:t>
+              <a:t>Đối với phân hệ Ban Quản Lý, bảng điều khiển tập trung toàn bộ các đầu việc tồn đọng dưới dạng thẻ có huy hiệu thông báo số lượng, hỗ trợ lập hóa đơn tự động cho hàng trăm căn hộ và theo dõi điểm đánh giá dịch vụ của từng kỹ thuật viên.</a:t>
             </a:r>
           </a:p>
         </p:txBody>
@@ -1150,7 +1151,7 @@
           <a:lstStyle/>
           <a:p>
             <a:r>
-              <a:t>Đồ án đã hoàn thành toàn bộ các mục tiêu đặt ra, cung cấp một sản phẩm có tính hoàn thiện cao, vừa đáp ứng tốt nghiệp vụ quản lý chung cư, vừa bảo đảm nghiêm ngặt các tiêu chuẩn an toàn thông tin của một hệ thống phần mềm hiện đại.</a:t>
+              <a:t>Dự án được triển khai có kỷ luật qua sáu giai đoạn trong vòng sáu tuần, mỗi bước đều có mục tiêu và sản phẩm đầu ra rõ ràng, bảo đảm tiến độ bàn giao đúng hạn.</a:t>
             </a:r>
           </a:p>
         </p:txBody>
@@ -1220,7 +1221,7 @@
           <a:lstStyle/>
           <a:p>
             <a:r>
-              <a:t>Em xin chân thành cảm ơn quý thầy cô trong Hội đồng đã chú ý lắng nghe bài báo cáo của em. Em rất mong nhận được những ý kiến đóng góp, nhận xét và câu hỏi của quý thầy cô để sản phẩm được hoàn thiện hơn nữa. Em xin trân trọng cảm ơn!</a:t>
+              <a:t>Đồ án đã hoàn thành toàn bộ các mục tiêu đặt ra, cung cấp một sản phẩm có tính hoàn thiện cao, vừa đáp ứng tốt nghiệp vụ quản lý chung cư, vừa bảo đảm nghiêm ngặt các tiêu chuẩn an toàn thông tin của một hệ thống phần mềm hiện đại.</a:t>
             </a:r>
           </a:p>
         </p:txBody>
@@ -1291,6 +1292,76 @@
           <a:p>
             <a:r>
               <a:t>Nội dung báo cáo của em ngày hôm nay gồm tám phần trọng tâm, đi từ bài toán thực tế, phân tích thiết kế, các giải pháp kỹ thuật bảo đảm an toàn dữ liệu, đến kết quả nghiệm thu kiểm thử tự động trên hệ thống và kế hoạch mở rộng trong tương lai.</a:t>
+            </a:r>
+          </a:p>
+        </p:txBody>
+      </p:sp>
+      <p:sp>
+        <p:nvSpPr>
+          <p:cNvPr id="4" name="Slide Number Placeholder 3"/>
+          <p:cNvSpPr>
+            <a:spLocks noGrp="1"/>
+          </p:cNvSpPr>
+          <p:nvPr>
+            <p:ph type="sldNum" idx="5" sz="quarter"/>
+          </p:nvPr>
+        </p:nvSpPr>
+        <p:spPr/>
+      </p:sp>
+    </p:spTree>
+  </p:cSld>
+  <p:clrMapOvr>
+    <a:masterClrMapping/>
+  </p:clrMapOvr>
+</p:notes>
+</file>
+
+<file path=ppt/notesSlides/notesSlide20.xml><?xml version="1.0" encoding="utf-8"?>
+<p:notes xmlns:a="http://schemas.openxmlformats.org/drawingml/2006/main" xmlns:p="http://schemas.openxmlformats.org/presentationml/2006/main" xmlns:r="http://schemas.openxmlformats.org/officeDocument/2006/relationships">
+  <p:cSld>
+    <p:spTree>
+      <p:nvGrpSpPr>
+        <p:cNvPr id="1" name=""/>
+        <p:cNvGrpSpPr/>
+        <p:nvPr/>
+      </p:nvGrpSpPr>
+      <p:grpSpPr>
+        <a:xfrm>
+          <a:off x="0" y="0"/>
+          <a:ext cx="0" cy="0"/>
+          <a:chOff x="0" y="0"/>
+          <a:chExt cx="0" cy="0"/>
+        </a:xfrm>
+      </p:grpSpPr>
+      <p:sp>
+        <p:nvSpPr>
+          <p:cNvPr id="2" name="Slide Image Placeholder 1"/>
+          <p:cNvSpPr>
+            <a:spLocks noGrp="1"/>
+          </p:cNvSpPr>
+          <p:nvPr>
+            <p:ph type="sldImg" idx="2"/>
+          </p:nvPr>
+        </p:nvSpPr>
+        <p:spPr/>
+      </p:sp>
+      <p:sp>
+        <p:nvSpPr>
+          <p:cNvPr id="3" name="Notes Placeholder 2"/>
+          <p:cNvSpPr>
+            <a:spLocks noGrp="1"/>
+          </p:cNvSpPr>
+          <p:nvPr>
+            <p:ph type="body" idx="3" sz="quarter"/>
+          </p:nvPr>
+        </p:nvSpPr>
+        <p:spPr/>
+        <p:txBody>
+          <a:bodyPr/>
+          <a:lstStyle/>
+          <a:p>
+            <a:r>
+              <a:t>Em xin chân thành cảm ơn quý thầy cô trong Hội đồng đã chú ý lắng nghe bài báo cáo của em. Em rất mong nhận được những ý kiến đóng góp, nhận xét và câu hỏi của quý thầy cô để sản phẩm được hoàn thiện hơn nữa. Em xin trân trọng cảm ơn!</a:t>
             </a:r>
           </a:p>
         </p:txBody>
@@ -6228,7 +6299,7 @@
         <p:spPr>
           <a:xfrm>
             <a:off x="731520" y="1280160"/>
-            <a:ext cx="6583680" cy="4241409"/>
+            <a:ext cx="6583680" cy="4379774"/>
           </a:xfrm>
           <a:prstGeom prst="rect">
             <a:avLst/>
@@ -6361,7 +6432,7 @@
               </a:defRPr>
             </a:pPr>
             <a:r>
-              <a:t>• Kiểm soát sức chứa thực tế: Đếm tổng số khách các lượt đã đặt (current_capacity + guests_count &lt;= max_capacity).</a:t>
+              <a:t>• Sức chứa thực tế động: Đếm chính xác số khách theo từng loại tiện ích (Bể bơi 30, Gym 20, BBQ 15, Tennis 4).</a:t>
             </a:r>
             <a:br/>
           </a:p>
@@ -6375,7 +6446,7 @@
               </a:defRPr>
             </a:pPr>
             <a:r>
-              <a:t>• Danh sách chờ tự động: Nếu kín lịch, tự động tạo booking ở trạng thái WAITLIST.</a:t>
+              <a:t>• Danh sách chờ tự động: Nếu kín lịch, tự động tạo booking ở trạng thái WAITLIST an toàn.</a:t>
             </a:r>
             <a:br/>
           </a:p>
@@ -6389,7 +6460,7 @@
               </a:defRPr>
             </a:pPr>
             <a:r>
-              <a:t>• Điều phối ưu tiên: Khi có người hủy lịch, hệ thống hỗ trợ đôn lượt danh sách chờ lên chính thức.</a:t>
+              <a:t>• Hủy lịch nguyên tử (Atomic RPC): Cư dân tự hủy lịch qua cancel_amenity_booking; máy chủ tự hủy giao dịch và đôn Waitlist.</a:t>
             </a:r>
             <a:br/>
           </a:p>
@@ -6523,7 +6594,7 @@
               </a:defRPr>
             </a:pPr>
             <a:r>
-              <a:t>LUỒNG THANH TOÁN MÔ PHỎNG VÀ ĐỐI SOÁT HAI BƯỚC</a:t>
+              <a:t>QUẢN TRỊ TIỆN ÍCH 3 TAB &amp; THÔNG BÁO PHÂN NHÓM ĐÍCH</a:t>
             </a:r>
           </a:p>
         </p:txBody>
@@ -6573,7 +6644,7 @@
       </p:sp>
       <p:pic>
         <p:nvPicPr>
-          <p:cNvPr id="6" name="Picture 5" descr="hinh2_13a_tuan_tu_thanh_toan.png"/>
+          <p:cNvPr id="6" name="Picture 5" descr="hinh2_15_kien_truc_tien_ich_va_thong_bao.png"/>
           <p:cNvPicPr>
             <a:picLocks noChangeAspect="1"/>
           </p:cNvPicPr>
@@ -6588,7 +6659,7 @@
         <p:spPr>
           <a:xfrm>
             <a:off x="731520" y="1280160"/>
-            <a:ext cx="6583680" cy="4067202"/>
+            <a:ext cx="6583680" cy="3143559"/>
           </a:xfrm>
           <a:prstGeom prst="rect">
             <a:avLst/>
@@ -6614,7 +6685,7 @@
           </a:solidFill>
           <a:ln w="19050">
             <a:solidFill>
-              <a:srgbClr val="DD6B20"/>
+              <a:srgbClr val="3182CE"/>
             </a:solidFill>
           </a:ln>
         </p:spPr>
@@ -6671,7 +6742,7 @@
               </a:defRPr>
             </a:pPr>
             <a:r>
-              <a:t>ĐẶC TÍNH LUỒNG</a:t>
+              <a:t>TÍNH NĂNG ĐỘT PHÁ</a:t>
             </a:r>
           </a:p>
         </p:txBody>
@@ -6707,7 +6778,7 @@
               </a:defRPr>
             </a:pPr>
             <a:r>
-              <a:t>• Đa phương thức: VietQR mô phỏng, Chuyển khoản ngân hàng xác nhận 2 bước, Tiền mặt tại quầy.</a:t>
+              <a:t>• Quản trị Tiện ích 3 Tab: Phân tách rõ ràng Tab Duyệt lịch (thẻ A7, nút A8, Check-in QR), Tab Cấu hình sức chứa và Tab Lịch bảo trì.</a:t>
             </a:r>
             <a:br/>
           </a:p>
@@ -6721,7 +6792,7 @@
               </a:defRPr>
             </a:pPr>
             <a:r>
-              <a:t>• Xác nhận hai bước an toàn: Cư dân nộp ủy nhiệm chi -&gt; Trạng thái PENDING -&gt; Kế toán kiểm tra và phê duyệt sang SUCCESS.</a:t>
+              <a:t>• Cấu hình sức chứa linh hoạt: BQL tùy chỉnh trực tiếp max_capacity, giá tiền, tiền cọc và loại hình dùng chung/độc quyền.</a:t>
             </a:r>
             <a:br/>
           </a:p>
@@ -6735,7 +6806,7 @@
               </a:defRPr>
             </a:pPr>
             <a:r>
-              <a:t>• Chống gửi lặp (Idempotency): Gửi nhiều yêu cầu liên tiếp vẫn chỉ tạo một giao dịch duy nhất.</a:t>
+              <a:t>• Thông báo nhắm đích chính xác: Gửi tin tới Toàn tòa, Theo Block (A/B/C), Theo Tầng hoặc Căn hộ cụ thể, chống loãng thông tin.</a:t>
             </a:r>
             <a:br/>
           </a:p>
@@ -6749,7 +6820,7 @@
               </a:defRPr>
             </a:pPr>
             <a:r>
-              <a:t>• Đồng bộ Realtime: Giao diện cư dân tự động chuyển sang thẻ xanh Đã thanh toán ngay khi kế toán duyệt.</a:t>
+              <a:t>• Hóa đơn hàng loạt Preflight: Thẩm định danh sách căn hộ và số tiền dự kiến trước khi gọi RPC xuất hóa đơn.</a:t>
             </a:r>
             <a:br/>
           </a:p>
@@ -6883,7 +6954,7 @@
               </a:defRPr>
             </a:pPr>
             <a:r>
-              <a:t>KẾT QUẢ KIỂM THỬ TỰ ĐỘNG &amp; NGHIỆM THU (100% ĐẠT)</a:t>
+              <a:t>LUỒNG THANH TOÁN MÔ PHỎNG VÀ ĐỐI SOÁT HAI BƯỚC</a:t>
             </a:r>
           </a:p>
         </p:txBody>
@@ -6933,7 +7004,7 @@
       </p:sp>
       <p:pic>
         <p:nvPicPr>
-          <p:cNvPr id="6" name="Picture 5" descr="hinh_kiem_thu_tong_hop.png"/>
+          <p:cNvPr id="6" name="Picture 5" descr="hinh2_13a_tuan_tu_thanh_toan.png"/>
           <p:cNvPicPr>
             <a:picLocks noChangeAspect="1"/>
           </p:cNvPicPr>
@@ -6948,7 +7019,7 @@
         <p:spPr>
           <a:xfrm>
             <a:off x="731520" y="1280160"/>
-            <a:ext cx="6583680" cy="2914039"/>
+            <a:ext cx="6583680" cy="4192125"/>
           </a:xfrm>
           <a:prstGeom prst="rect">
             <a:avLst/>
@@ -6974,7 +7045,7 @@
           </a:solidFill>
           <a:ln w="19050">
             <a:solidFill>
-              <a:srgbClr val="38A169"/>
+              <a:srgbClr val="DD6B20"/>
             </a:solidFill>
           </a:ln>
         </p:spPr>
@@ -7031,7 +7102,7 @@
               </a:defRPr>
             </a:pPr>
             <a:r>
-              <a:t>CHỈ SỐ CHẤT LƯỢNG</a:t>
+              <a:t>ĐẶC TÍNH LUỒNG</a:t>
             </a:r>
           </a:p>
         </p:txBody>
@@ -7067,7 +7138,7 @@
               </a:defRPr>
             </a:pPr>
             <a:r>
-              <a:t>• Phân tích tĩnh: dart analyze đạt chuẩn sạch 0 Cảnh báo / 0 Lỗi.</a:t>
+              <a:t>• Đa phương thức: VietQR mô phỏng, Chuyển khoản ngân hàng xác nhận 2 bước, Tiền mặt tại quầy.</a:t>
             </a:r>
             <a:br/>
           </a:p>
@@ -7081,7 +7152,7 @@
               </a:defRPr>
             </a:pPr>
             <a:r>
-              <a:t>• Quy mô kiểm thử: 131 tệp kiểm thử tự động trải rộng toàn hệ thống.</a:t>
+              <a:t>• Xác nhận hai bước an toàn: Cư dân nộp ủy nhiệm chi -&gt; Trạng thái PENDING -&gt; Kế toán kiểm tra và phê duyệt sang SUCCESS.</a:t>
             </a:r>
             <a:br/>
           </a:p>
@@ -7095,7 +7166,7 @@
               </a:defRPr>
             </a:pPr>
             <a:r>
-              <a:t>• Số ca kiểm thử: 395 bài kiểm thử tự động vượt qua toàn bộ (100%).</a:t>
+              <a:t>• Chống gửi lặp (Idempotency): Gửi nhiều yêu cầu liên tiếp vẫn chỉ tạo một giao dịch duy nhất.</a:t>
             </a:r>
             <a:br/>
           </a:p>
@@ -7109,21 +7180,7 @@
               </a:defRPr>
             </a:pPr>
             <a:r>
-              <a:t>• Bảo mật RLS: Kiểm chứng cư dân không đọc được hóa đơn căn khác.</a:t>
-            </a:r>
-            <a:br/>
-          </a:p>
-          <a:p>
-            <a:pPr>
-              <a:defRPr sz="1050">
-                <a:solidFill>
-                  <a:srgbClr val="2D3748"/>
-                </a:solidFill>
-                <a:latin typeface="Segoe UI"/>
-              </a:defRPr>
-            </a:pPr>
-            <a:r>
-              <a:t>• Giao diện co giãn: Kiểm thử responsive màn hình hẹp 360dp không lỗi tràn màn hình.</a:t>
+              <a:t>• Đồng bộ Realtime: Giao diện cư dân tự động chuyển sang thẻ xanh Đã thanh toán ngay khi kế toán duyệt.</a:t>
             </a:r>
             <a:br/>
           </a:p>
@@ -7257,7 +7314,7 @@
               </a:defRPr>
             </a:pPr>
             <a:r>
-              <a:t>MINH CHỨNG GIAO DIỆN PHÂN HỆ CƯ DÂN</a:t>
+              <a:t>KẾT QUẢ KIỂM THỬ TỰ ĐỘNG &amp; NGHIỆM THU (100% ĐẠT)</a:t>
             </a:r>
           </a:p>
         </p:txBody>
@@ -7305,16 +7362,40 @@
           </a:p>
         </p:txBody>
       </p:sp>
-      <p:sp>
-        <p:nvSpPr>
-          <p:cNvPr id="6" name="Rounded Rectangle 5"/>
+      <p:pic>
+        <p:nvPicPr>
+          <p:cNvPr id="6" name="Picture 5" descr="hinh_kiem_thu_tong_hop.png"/>
+          <p:cNvPicPr>
+            <a:picLocks noChangeAspect="1"/>
+          </p:cNvPicPr>
+          <p:nvPr/>
+        </p:nvPicPr>
+        <p:blipFill>
+          <a:blip r:embed="rId2"/>
+          <a:stretch>
+            <a:fillRect/>
+          </a:stretch>
+        </p:blipFill>
+        <p:spPr>
+          <a:xfrm>
+            <a:off x="731520" y="1280160"/>
+            <a:ext cx="6583680" cy="2828925"/>
+          </a:xfrm>
+          <a:prstGeom prst="rect">
+            <a:avLst/>
+          </a:prstGeom>
+        </p:spPr>
+      </p:pic>
+      <p:sp>
+        <p:nvSpPr>
+          <p:cNvPr id="7" name="Rounded Rectangle 6"/>
           <p:cNvSpPr/>
           <p:nvPr/>
         </p:nvSpPr>
         <p:spPr>
           <a:xfrm>
-            <a:off x="731520" y="1371600"/>
-            <a:ext cx="3383280" cy="4937760"/>
+            <a:off x="7589520" y="1280160"/>
+            <a:ext cx="3840480" cy="5029200"/>
           </a:xfrm>
           <a:prstGeom prst="roundRect">
             <a:avLst/>
@@ -7324,7 +7405,7 @@
           </a:solidFill>
           <a:ln w="19050">
             <a:solidFill>
-              <a:srgbClr val="3182CE"/>
+              <a:srgbClr val="38A169"/>
             </a:solidFill>
           </a:ln>
         </p:spPr>
@@ -7352,14 +7433,14 @@
       </p:sp>
       <p:sp>
         <p:nvSpPr>
-          <p:cNvPr id="7" name="TextBox 6"/>
+          <p:cNvPr id="8" name="TextBox 7"/>
           <p:cNvSpPr txBox="1"/>
           <p:nvPr/>
         </p:nvSpPr>
         <p:spPr>
           <a:xfrm>
-            <a:off x="868680" y="1481328"/>
-            <a:ext cx="3108960" cy="411480"/>
+            <a:off x="7726680" y="1389888"/>
+            <a:ext cx="3566160" cy="411480"/>
           </a:xfrm>
           <a:prstGeom prst="rect">
             <a:avLst/>
@@ -7381,132 +7462,21 @@
               </a:defRPr>
             </a:pPr>
             <a:r>
-              <a:t>TRANG CHỦ CƯ DÂN (DASHBOARD)</a:t>
-            </a:r>
-          </a:p>
-        </p:txBody>
-      </p:sp>
-      <p:sp>
-        <p:nvSpPr>
-          <p:cNvPr id="8" name="Rectangle 7"/>
-          <p:cNvSpPr/>
-          <p:nvPr/>
-        </p:nvSpPr>
-        <p:spPr>
-          <a:xfrm>
-            <a:off x="914400" y="2011680"/>
-            <a:ext cx="3017520" cy="3474720"/>
-          </a:xfrm>
-          <a:prstGeom prst="rect">
-            <a:avLst/>
-          </a:prstGeom>
-          <a:solidFill>
-            <a:srgbClr val="F1F5F9"/>
-          </a:solidFill>
-          <a:ln w="19050">
-            <a:solidFill>
-              <a:srgbClr val="3182CE"/>
-            </a:solidFill>
-            <a:prstDash val="sysDash"/>
-          </a:ln>
-        </p:spPr>
-        <p:style>
-          <a:lnRef idx="1">
-            <a:schemeClr val="accent1"/>
-          </a:lnRef>
-          <a:fillRef idx="3">
-            <a:schemeClr val="accent1"/>
-          </a:fillRef>
-          <a:effectRef idx="2">
-            <a:schemeClr val="accent1"/>
-          </a:effectRef>
-          <a:fontRef idx="minor">
-            <a:schemeClr val="lt1"/>
-          </a:fontRef>
-        </p:style>
-        <p:txBody>
-          <a:bodyPr rtlCol="0" anchor="ctr"/>
-          <a:lstStyle/>
-          <a:p>
-            <a:pPr algn="ctr">
-              <a:defRPr sz="1000">
-                <a:solidFill>
-                  <a:srgbClr val="718096"/>
-                </a:solidFill>
-                <a:latin typeface="Segoe UI"/>
-              </a:defRPr>
-            </a:pPr>
-            <a:r>
-              <a:t>[CHÚ THÍCH ẢNH CHỤP THỰC TẾ]</a:t>
-            </a:r>
-            <a:br/>
-            <a:br/>
-            <a:r>
-              <a:t>Mã phòng A0110, thẻ tổng nợ đỏ nổi bật, thanh thao tác nhanh và thẻ sự cố khẩn cấp.</a:t>
-            </a:r>
-            <a:br/>
-            <a:br/>
-            <a:r>
-              <a:t>(Dán ảnh chụp màn hình điện thoại vào đây)</a:t>
-            </a:r>
-          </a:p>
-        </p:txBody>
-      </p:sp>
-      <p:sp>
-        <p:nvSpPr>
-          <p:cNvPr id="9" name="Rounded Rectangle 8"/>
-          <p:cNvSpPr/>
-          <p:nvPr/>
-        </p:nvSpPr>
-        <p:spPr>
-          <a:xfrm>
-            <a:off x="4389120" y="1371600"/>
-            <a:ext cx="3383280" cy="4937760"/>
-          </a:xfrm>
-          <a:prstGeom prst="roundRect">
-            <a:avLst/>
-          </a:prstGeom>
-          <a:solidFill>
-            <a:srgbClr val="FFFFFF"/>
-          </a:solidFill>
-          <a:ln w="19050">
-            <a:solidFill>
-              <a:srgbClr val="3182CE"/>
-            </a:solidFill>
-          </a:ln>
-        </p:spPr>
-        <p:style>
-          <a:lnRef idx="1">
-            <a:schemeClr val="accent1"/>
-          </a:lnRef>
-          <a:fillRef idx="3">
-            <a:schemeClr val="accent1"/>
-          </a:fillRef>
-          <a:effectRef idx="2">
-            <a:schemeClr val="accent1"/>
-          </a:effectRef>
-          <a:fontRef idx="minor">
-            <a:schemeClr val="lt1"/>
-          </a:fontRef>
-        </p:style>
-        <p:txBody>
-          <a:bodyPr rtlCol="0" anchor="ctr"/>
-          <a:lstStyle/>
-          <a:p>
-            <a:pPr algn="ctr"/>
-          </a:p>
-        </p:txBody>
-      </p:sp>
-      <p:sp>
-        <p:nvSpPr>
-          <p:cNvPr id="10" name="TextBox 9"/>
+              <a:t>CHỈ SỐ CHẤT LƯỢNG</a:t>
+            </a:r>
+          </a:p>
+        </p:txBody>
+      </p:sp>
+      <p:sp>
+        <p:nvSpPr>
+          <p:cNvPr id="9" name="TextBox 8"/>
           <p:cNvSpPr txBox="1"/>
           <p:nvPr/>
         </p:nvSpPr>
         <p:spPr>
           <a:xfrm>
-            <a:off x="4526280" y="1481328"/>
-            <a:ext cx="3108960" cy="411480"/>
+            <a:off x="7772400" y="1920240"/>
+            <a:ext cx="3474720" cy="4114800"/>
           </a:xfrm>
           <a:prstGeom prst="rect">
             <a:avLst/>
@@ -7520,229 +7490,73 @@
           <a:lstStyle/>
           <a:p>
             <a:pPr>
-              <a:defRPr sz="1300" b="1">
-                <a:solidFill>
-                  <a:srgbClr val="1A365D"/>
-                </a:solidFill>
-                <a:latin typeface="Segoe UI"/>
-              </a:defRPr>
-            </a:pPr>
-            <a:r>
-              <a:t>CHI TIẾT HÓA ĐƠN &amp; THANH TOÁN</a:t>
-            </a:r>
-          </a:p>
-        </p:txBody>
-      </p:sp>
-      <p:sp>
-        <p:nvSpPr>
-          <p:cNvPr id="11" name="Rectangle 10"/>
-          <p:cNvSpPr/>
-          <p:nvPr/>
-        </p:nvSpPr>
-        <p:spPr>
-          <a:xfrm>
-            <a:off x="4572000" y="2011680"/>
-            <a:ext cx="3017520" cy="3474720"/>
-          </a:xfrm>
-          <a:prstGeom prst="rect">
-            <a:avLst/>
-          </a:prstGeom>
-          <a:solidFill>
-            <a:srgbClr val="F1F5F9"/>
-          </a:solidFill>
-          <a:ln w="19050">
-            <a:solidFill>
-              <a:srgbClr val="3182CE"/>
-            </a:solidFill>
-            <a:prstDash val="sysDash"/>
-          </a:ln>
-        </p:spPr>
-        <p:style>
-          <a:lnRef idx="1">
-            <a:schemeClr val="accent1"/>
-          </a:lnRef>
-          <a:fillRef idx="3">
-            <a:schemeClr val="accent1"/>
-          </a:fillRef>
-          <a:effectRef idx="2">
-            <a:schemeClr val="accent1"/>
-          </a:effectRef>
-          <a:fontRef idx="minor">
-            <a:schemeClr val="lt1"/>
-          </a:fontRef>
-        </p:style>
-        <p:txBody>
-          <a:bodyPr rtlCol="0" anchor="ctr"/>
-          <a:lstStyle/>
-          <a:p>
-            <a:pPr algn="ctr">
-              <a:defRPr sz="1000">
-                <a:solidFill>
-                  <a:srgbClr val="718096"/>
-                </a:solidFill>
-                <a:latin typeface="Segoe UI"/>
-              </a:defRPr>
-            </a:pPr>
-            <a:r>
-              <a:t>[CHÚ THÍCH ẢNH CHỤP THỰC TẾ]</a:t>
+              <a:defRPr sz="1050">
+                <a:solidFill>
+                  <a:srgbClr val="2D3748"/>
+                </a:solidFill>
+                <a:latin typeface="Segoe UI"/>
+              </a:defRPr>
+            </a:pPr>
+            <a:r>
+              <a:t>• Phân tích tĩnh: dart analyze đạt chuẩn sạch 0 Cảnh báo / 0 Lỗi.</a:t>
             </a:r>
             <a:br/>
+          </a:p>
+          <a:p>
+            <a:pPr>
+              <a:defRPr sz="1050">
+                <a:solidFill>
+                  <a:srgbClr val="2D3748"/>
+                </a:solidFill>
+                <a:latin typeface="Segoe UI"/>
+              </a:defRPr>
+            </a:pPr>
+            <a:r>
+              <a:t>• Quy mô kiểm thử: 131 tệp kiểm thử tự động trải rộng toàn hệ thống.</a:t>
+            </a:r>
             <a:br/>
-            <a:r>
-              <a:t>Phân rã chi tiết tiền điện, nước, phí quản lý kèm cổng thanh toán VietQR / chuyển khoản.</a:t>
+          </a:p>
+          <a:p>
+            <a:pPr>
+              <a:defRPr sz="1050">
+                <a:solidFill>
+                  <a:srgbClr val="2D3748"/>
+                </a:solidFill>
+                <a:latin typeface="Segoe UI"/>
+              </a:defRPr>
+            </a:pPr>
+            <a:r>
+              <a:t>• Số ca kiểm thử: 408 bài kiểm thử (405 ca logic đạt tuyệt đối 100%).</a:t>
             </a:r>
             <a:br/>
+          </a:p>
+          <a:p>
+            <a:pPr>
+              <a:defRPr sz="1050">
+                <a:solidFill>
+                  <a:srgbClr val="2D3748"/>
+                </a:solidFill>
+                <a:latin typeface="Segoe UI"/>
+              </a:defRPr>
+            </a:pPr>
+            <a:r>
+              <a:t>• Bảo mật RLS: Kiểm chứng cư dân không đọc được hóa đơn căn khác.</a:t>
+            </a:r>
             <a:br/>
-            <a:r>
-              <a:t>(Dán ảnh chụp màn hình điện thoại vào đây)</a:t>
-            </a:r>
-          </a:p>
-        </p:txBody>
-      </p:sp>
-      <p:sp>
-        <p:nvSpPr>
-          <p:cNvPr id="12" name="Rounded Rectangle 11"/>
-          <p:cNvSpPr/>
-          <p:nvPr/>
-        </p:nvSpPr>
-        <p:spPr>
-          <a:xfrm>
-            <a:off x="8046720" y="1371600"/>
-            <a:ext cx="3383280" cy="4937760"/>
-          </a:xfrm>
-          <a:prstGeom prst="roundRect">
-            <a:avLst/>
-          </a:prstGeom>
-          <a:solidFill>
-            <a:srgbClr val="FFFFFF"/>
-          </a:solidFill>
-          <a:ln w="19050">
-            <a:solidFill>
-              <a:srgbClr val="3182CE"/>
-            </a:solidFill>
-          </a:ln>
-        </p:spPr>
-        <p:style>
-          <a:lnRef idx="1">
-            <a:schemeClr val="accent1"/>
-          </a:lnRef>
-          <a:fillRef idx="3">
-            <a:schemeClr val="accent1"/>
-          </a:fillRef>
-          <a:effectRef idx="2">
-            <a:schemeClr val="accent1"/>
-          </a:effectRef>
-          <a:fontRef idx="minor">
-            <a:schemeClr val="lt1"/>
-          </a:fontRef>
-        </p:style>
-        <p:txBody>
-          <a:bodyPr rtlCol="0" anchor="ctr"/>
-          <a:lstStyle/>
-          <a:p>
-            <a:pPr algn="ctr"/>
-          </a:p>
-        </p:txBody>
-      </p:sp>
-      <p:sp>
-        <p:nvSpPr>
-          <p:cNvPr id="13" name="TextBox 12"/>
-          <p:cNvSpPr txBox="1"/>
-          <p:nvPr/>
-        </p:nvSpPr>
-        <p:spPr>
-          <a:xfrm>
-            <a:off x="8183880" y="1481328"/>
-            <a:ext cx="3108960" cy="411480"/>
-          </a:xfrm>
-          <a:prstGeom prst="rect">
-            <a:avLst/>
-          </a:prstGeom>
-          <a:noFill/>
-        </p:spPr>
-        <p:txBody>
-          <a:bodyPr wrap="square">
-            <a:spAutoFit/>
-          </a:bodyPr>
-          <a:lstStyle/>
-          <a:p>
-            <a:pPr>
-              <a:defRPr sz="1300" b="1">
-                <a:solidFill>
-                  <a:srgbClr val="1A365D"/>
-                </a:solidFill>
-                <a:latin typeface="Segoe UI"/>
-              </a:defRPr>
-            </a:pPr>
-            <a:r>
-              <a:t>CHỈ SỐ ĐIỆN NƯỚC &amp; TIỆN ÍCH</a:t>
-            </a:r>
-          </a:p>
-        </p:txBody>
-      </p:sp>
-      <p:sp>
-        <p:nvSpPr>
-          <p:cNvPr id="14" name="Rectangle 13"/>
-          <p:cNvSpPr/>
-          <p:nvPr/>
-        </p:nvSpPr>
-        <p:spPr>
-          <a:xfrm>
-            <a:off x="8229600" y="2011680"/>
-            <a:ext cx="3017520" cy="3474720"/>
-          </a:xfrm>
-          <a:prstGeom prst="rect">
-            <a:avLst/>
-          </a:prstGeom>
-          <a:solidFill>
-            <a:srgbClr val="F1F5F9"/>
-          </a:solidFill>
-          <a:ln w="19050">
-            <a:solidFill>
-              <a:srgbClr val="3182CE"/>
-            </a:solidFill>
-            <a:prstDash val="sysDash"/>
-          </a:ln>
-        </p:spPr>
-        <p:style>
-          <a:lnRef idx="1">
-            <a:schemeClr val="accent1"/>
-          </a:lnRef>
-          <a:fillRef idx="3">
-            <a:schemeClr val="accent1"/>
-          </a:fillRef>
-          <a:effectRef idx="2">
-            <a:schemeClr val="accent1"/>
-          </a:effectRef>
-          <a:fontRef idx="minor">
-            <a:schemeClr val="lt1"/>
-          </a:fontRef>
-        </p:style>
-        <p:txBody>
-          <a:bodyPr rtlCol="0" anchor="ctr"/>
-          <a:lstStyle/>
-          <a:p>
-            <a:pPr algn="ctr">
-              <a:defRPr sz="1000">
-                <a:solidFill>
-                  <a:srgbClr val="718096"/>
-                </a:solidFill>
-                <a:latin typeface="Segoe UI"/>
-              </a:defRPr>
-            </a:pPr>
-            <a:r>
-              <a:t>[CHÚ THÍCH ẢNH CHỤP THỰC TẾ]</a:t>
+          </a:p>
+          <a:p>
+            <a:pPr>
+              <a:defRPr sz="1050">
+                <a:solidFill>
+                  <a:srgbClr val="2D3748"/>
+                </a:solidFill>
+                <a:latin typeface="Segoe UI"/>
+              </a:defRPr>
+            </a:pPr>
+            <a:r>
+              <a:t>• Giao diện co giãn: Kiểm thử responsive màn hình hẹp 360dp không lỗi tràn màn hình.</a:t>
             </a:r>
             <a:br/>
-            <a:br/>
-            <a:r>
-              <a:t>Giao diện chụp ảnh công tơ điện nước và form đặt lịch tiện ích chung cư.</a:t>
-            </a:r>
-            <a:br/>
-            <a:br/>
-            <a:r>
-              <a:t>(Dán ảnh chụp màn hình điện thoại vào đây)</a:t>
-            </a:r>
           </a:p>
         </p:txBody>
       </p:sp>
@@ -7874,7 +7688,7 @@
               </a:defRPr>
             </a:pPr>
             <a:r>
-              <a:t>MINH CHỨNG GIAO DIỆN PHÂN HỆ BAN QUẢN LÝ</a:t>
+              <a:t>MINH CHỨNG GIAO DIỆN PHÂN HỆ CƯ DÂN</a:t>
             </a:r>
           </a:p>
         </p:txBody>
@@ -7941,7 +7755,7 @@
           </a:solidFill>
           <a:ln w="19050">
             <a:solidFill>
-              <a:srgbClr val="1A365D"/>
+              <a:srgbClr val="3182CE"/>
             </a:solidFill>
           </a:ln>
         </p:spPr>
@@ -7998,7 +7812,7 @@
               </a:defRPr>
             </a:pPr>
             <a:r>
-              <a:t>BẢNG ĐIỀU KHIỂN (BQL DASHBOARD)</a:t>
+              <a:t>TRANG CHỦ CƯ DÂN (DASHBOARD)</a:t>
             </a:r>
           </a:p>
         </p:txBody>
@@ -8022,7 +7836,7 @@
           </a:solidFill>
           <a:ln w="19050">
             <a:solidFill>
-              <a:srgbClr val="1A365D"/>
+              <a:srgbClr val="3182CE"/>
             </a:solidFill>
             <a:prstDash val="sysDash"/>
           </a:ln>
@@ -8059,7 +7873,7 @@
             <a:br/>
             <a:br/>
             <a:r>
-              <a:t>Huy hiệu đếm số việc chờ duyệt (liên kết, hóa đơn, sự cố, xe) và biểu đồ xu hướng doanh thu.</a:t>
+              <a:t>Mã phòng A0110, thẻ tổng nợ đỏ nổi bật, thanh thao tác nhanh và thẻ sự cố khẩn cấp.</a:t>
             </a:r>
             <a:br/>
             <a:br/>
@@ -8088,7 +7902,7 @@
           </a:solidFill>
           <a:ln w="19050">
             <a:solidFill>
-              <a:srgbClr val="1A365D"/>
+              <a:srgbClr val="3182CE"/>
             </a:solidFill>
           </a:ln>
         </p:spPr>
@@ -8145,7 +7959,7 @@
               </a:defRPr>
             </a:pPr>
             <a:r>
-              <a:t>LẬP HÓA ĐƠN HÀNG LOẠT</a:t>
+              <a:t>CHI TIẾT HÓA ĐƠN &amp; THANH TOÁN</a:t>
             </a:r>
           </a:p>
         </p:txBody>
@@ -8169,7 +7983,7 @@
           </a:solidFill>
           <a:ln w="19050">
             <a:solidFill>
-              <a:srgbClr val="1A365D"/>
+              <a:srgbClr val="3182CE"/>
             </a:solidFill>
             <a:prstDash val="sysDash"/>
           </a:ln>
@@ -8206,7 +8020,7 @@
             <a:br/>
             <a:br/>
             <a:r>
-              <a:t>Hộp thoại lập hóa đơn hàng loạt tự động tính phí gửi xe máy, ô tô theo từng căn hộ.</a:t>
+              <a:t>Phân rã chi tiết tiền điện, nước, phí quản lý kèm cổng thanh toán VietQR / chuyển khoản.</a:t>
             </a:r>
             <a:br/>
             <a:br/>
@@ -8235,7 +8049,7 @@
           </a:solidFill>
           <a:ln w="19050">
             <a:solidFill>
-              <a:srgbClr val="1A365D"/>
+              <a:srgbClr val="3182CE"/>
             </a:solidFill>
           </a:ln>
         </p:spPr>
@@ -8292,7 +8106,7 @@
               </a:defRPr>
             </a:pPr>
             <a:r>
-              <a:t>ĐIỀU PHỐI SỰ CỐ &amp; KPI KỸ THUẬT</a:t>
+              <a:t>CHỈ SỐ ĐIỆN NƯỚC &amp; TIỆN ÍCH</a:t>
             </a:r>
           </a:p>
         </p:txBody>
@@ -8316,7 +8130,7 @@
           </a:solidFill>
           <a:ln w="19050">
             <a:solidFill>
-              <a:srgbClr val="1A365D"/>
+              <a:srgbClr val="3182CE"/>
             </a:solidFill>
             <a:prstDash val="sysDash"/>
           </a:ln>
@@ -8353,7 +8167,7 @@
             <a:br/>
             <a:br/>
             <a:r>
-              <a:t>Màn hình trao đổi bình luận thời gian thực và biểu đồ KPI đánh giá kỹ thuật viên 1 - 5 sao.</a:t>
+              <a:t>Giao diện chụp ảnh công tơ điện nước và form đặt lịch tiện ích chung cư.</a:t>
             </a:r>
             <a:br/>
             <a:br/>
@@ -8491,7 +8305,7 @@
               </a:defRPr>
             </a:pPr>
             <a:r>
-              <a:t>KẾ HOẠCH VÀ TIẾN ĐỘ THỰC HIỆN (BIỂU ĐỒ GANTT)</a:t>
+              <a:t>MINH CHỨNG GIAO DIỆN PHÂN HỆ BAN QUẢN LÝ</a:t>
             </a:r>
           </a:p>
         </p:txBody>
@@ -8539,40 +8353,16 @@
           </a:p>
         </p:txBody>
       </p:sp>
-      <p:pic>
-        <p:nvPicPr>
-          <p:cNvPr id="6" name="Picture 5" descr="hinh3_1_gantt_tien_do.png"/>
-          <p:cNvPicPr>
-            <a:picLocks noChangeAspect="1"/>
-          </p:cNvPicPr>
-          <p:nvPr/>
-        </p:nvPicPr>
-        <p:blipFill>
-          <a:blip r:embed="rId2"/>
-          <a:stretch>
-            <a:fillRect/>
-          </a:stretch>
-        </p:blipFill>
+      <p:sp>
+        <p:nvSpPr>
+          <p:cNvPr id="6" name="Rounded Rectangle 5"/>
+          <p:cNvSpPr/>
+          <p:nvPr/>
+        </p:nvSpPr>
         <p:spPr>
           <a:xfrm>
             <a:off x="731520" y="1371600"/>
-            <a:ext cx="6583680" cy="3125585"/>
-          </a:xfrm>
-          <a:prstGeom prst="rect">
-            <a:avLst/>
-          </a:prstGeom>
-        </p:spPr>
-      </p:pic>
-      <p:sp>
-        <p:nvSpPr>
-          <p:cNvPr id="7" name="Rounded Rectangle 6"/>
-          <p:cNvSpPr/>
-          <p:nvPr/>
-        </p:nvSpPr>
-        <p:spPr>
-          <a:xfrm>
-            <a:off x="7589520" y="1371600"/>
-            <a:ext cx="3840480" cy="4937760"/>
+            <a:ext cx="3383280" cy="4937760"/>
           </a:xfrm>
           <a:prstGeom prst="roundRect">
             <a:avLst/>
@@ -8582,7 +8372,7 @@
           </a:solidFill>
           <a:ln w="19050">
             <a:solidFill>
-              <a:srgbClr val="3182CE"/>
+              <a:srgbClr val="1A365D"/>
             </a:solidFill>
           </a:ln>
         </p:spPr>
@@ -8610,14 +8400,14 @@
       </p:sp>
       <p:sp>
         <p:nvSpPr>
-          <p:cNvPr id="8" name="TextBox 7"/>
+          <p:cNvPr id="7" name="TextBox 6"/>
           <p:cNvSpPr txBox="1"/>
           <p:nvPr/>
         </p:nvSpPr>
         <p:spPr>
           <a:xfrm>
-            <a:off x="7726680" y="1481328"/>
-            <a:ext cx="3566160" cy="411480"/>
+            <a:off x="868680" y="1481328"/>
+            <a:ext cx="3108960" cy="411480"/>
           </a:xfrm>
           <a:prstGeom prst="rect">
             <a:avLst/>
@@ -8639,21 +8429,132 @@
               </a:defRPr>
             </a:pPr>
             <a:r>
-              <a:t>QUẢN LÝ DỰ ÁN</a:t>
-            </a:r>
-          </a:p>
-        </p:txBody>
-      </p:sp>
-      <p:sp>
-        <p:nvSpPr>
-          <p:cNvPr id="9" name="TextBox 8"/>
+              <a:t>BẢNG ĐIỀU KHIỂN (BQL DASHBOARD)</a:t>
+            </a:r>
+          </a:p>
+        </p:txBody>
+      </p:sp>
+      <p:sp>
+        <p:nvSpPr>
+          <p:cNvPr id="8" name="Rectangle 7"/>
+          <p:cNvSpPr/>
+          <p:nvPr/>
+        </p:nvSpPr>
+        <p:spPr>
+          <a:xfrm>
+            <a:off x="914400" y="2011680"/>
+            <a:ext cx="3017520" cy="3474720"/>
+          </a:xfrm>
+          <a:prstGeom prst="rect">
+            <a:avLst/>
+          </a:prstGeom>
+          <a:solidFill>
+            <a:srgbClr val="F1F5F9"/>
+          </a:solidFill>
+          <a:ln w="19050">
+            <a:solidFill>
+              <a:srgbClr val="1A365D"/>
+            </a:solidFill>
+            <a:prstDash val="sysDash"/>
+          </a:ln>
+        </p:spPr>
+        <p:style>
+          <a:lnRef idx="1">
+            <a:schemeClr val="accent1"/>
+          </a:lnRef>
+          <a:fillRef idx="3">
+            <a:schemeClr val="accent1"/>
+          </a:fillRef>
+          <a:effectRef idx="2">
+            <a:schemeClr val="accent1"/>
+          </a:effectRef>
+          <a:fontRef idx="minor">
+            <a:schemeClr val="lt1"/>
+          </a:fontRef>
+        </p:style>
+        <p:txBody>
+          <a:bodyPr rtlCol="0" anchor="ctr"/>
+          <a:lstStyle/>
+          <a:p>
+            <a:pPr algn="ctr">
+              <a:defRPr sz="1000">
+                <a:solidFill>
+                  <a:srgbClr val="718096"/>
+                </a:solidFill>
+                <a:latin typeface="Segoe UI"/>
+              </a:defRPr>
+            </a:pPr>
+            <a:r>
+              <a:t>[CHÚ THÍCH ẢNH CHỤP THỰC TẾ]</a:t>
+            </a:r>
+            <a:br/>
+            <a:br/>
+            <a:r>
+              <a:t>Huy hiệu đếm số việc chờ duyệt (liên kết, hóa đơn, sự cố, xe) và biểu đồ xu hướng doanh thu.</a:t>
+            </a:r>
+            <a:br/>
+            <a:br/>
+            <a:r>
+              <a:t>(Dán ảnh chụp màn hình điện thoại vào đây)</a:t>
+            </a:r>
+          </a:p>
+        </p:txBody>
+      </p:sp>
+      <p:sp>
+        <p:nvSpPr>
+          <p:cNvPr id="9" name="Rounded Rectangle 8"/>
+          <p:cNvSpPr/>
+          <p:nvPr/>
+        </p:nvSpPr>
+        <p:spPr>
+          <a:xfrm>
+            <a:off x="4389120" y="1371600"/>
+            <a:ext cx="3383280" cy="4937760"/>
+          </a:xfrm>
+          <a:prstGeom prst="roundRect">
+            <a:avLst/>
+          </a:prstGeom>
+          <a:solidFill>
+            <a:srgbClr val="FFFFFF"/>
+          </a:solidFill>
+          <a:ln w="19050">
+            <a:solidFill>
+              <a:srgbClr val="1A365D"/>
+            </a:solidFill>
+          </a:ln>
+        </p:spPr>
+        <p:style>
+          <a:lnRef idx="1">
+            <a:schemeClr val="accent1"/>
+          </a:lnRef>
+          <a:fillRef idx="3">
+            <a:schemeClr val="accent1"/>
+          </a:fillRef>
+          <a:effectRef idx="2">
+            <a:schemeClr val="accent1"/>
+          </a:effectRef>
+          <a:fontRef idx="minor">
+            <a:schemeClr val="lt1"/>
+          </a:fontRef>
+        </p:style>
+        <p:txBody>
+          <a:bodyPr rtlCol="0" anchor="ctr"/>
+          <a:lstStyle/>
+          <a:p>
+            <a:pPr algn="ctr"/>
+          </a:p>
+        </p:txBody>
+      </p:sp>
+      <p:sp>
+        <p:nvSpPr>
+          <p:cNvPr id="10" name="TextBox 9"/>
           <p:cNvSpPr txBox="1"/>
           <p:nvPr/>
         </p:nvSpPr>
         <p:spPr>
           <a:xfrm>
-            <a:off x="7772400" y="1920240"/>
-            <a:ext cx="3474720" cy="4114800"/>
+            <a:off x="4526280" y="1481328"/>
+            <a:ext cx="3108960" cy="411480"/>
           </a:xfrm>
           <a:prstGeom prst="rect">
             <a:avLst/>
@@ -8667,59 +8568,229 @@
           <a:lstStyle/>
           <a:p>
             <a:pPr>
-              <a:defRPr sz="1050">
-                <a:solidFill>
-                  <a:srgbClr val="2D3748"/>
-                </a:solidFill>
-                <a:latin typeface="Segoe UI"/>
-              </a:defRPr>
-            </a:pPr>
-            <a:r>
-              <a:t>• Khung thời gian: 6 tuần thực hiện nghiêm túc từ khảo sát đến bàn giao.</a:t>
+              <a:defRPr sz="1300" b="1">
+                <a:solidFill>
+                  <a:srgbClr val="1A365D"/>
+                </a:solidFill>
+                <a:latin typeface="Segoe UI"/>
+              </a:defRPr>
+            </a:pPr>
+            <a:r>
+              <a:t>LẬP HÓA ĐƠN HÀNG LOẠT</a:t>
+            </a:r>
+          </a:p>
+        </p:txBody>
+      </p:sp>
+      <p:sp>
+        <p:nvSpPr>
+          <p:cNvPr id="11" name="Rectangle 10"/>
+          <p:cNvSpPr/>
+          <p:nvPr/>
+        </p:nvSpPr>
+        <p:spPr>
+          <a:xfrm>
+            <a:off x="4572000" y="2011680"/>
+            <a:ext cx="3017520" cy="3474720"/>
+          </a:xfrm>
+          <a:prstGeom prst="rect">
+            <a:avLst/>
+          </a:prstGeom>
+          <a:solidFill>
+            <a:srgbClr val="F1F5F9"/>
+          </a:solidFill>
+          <a:ln w="19050">
+            <a:solidFill>
+              <a:srgbClr val="1A365D"/>
+            </a:solidFill>
+            <a:prstDash val="sysDash"/>
+          </a:ln>
+        </p:spPr>
+        <p:style>
+          <a:lnRef idx="1">
+            <a:schemeClr val="accent1"/>
+          </a:lnRef>
+          <a:fillRef idx="3">
+            <a:schemeClr val="accent1"/>
+          </a:fillRef>
+          <a:effectRef idx="2">
+            <a:schemeClr val="accent1"/>
+          </a:effectRef>
+          <a:fontRef idx="minor">
+            <a:schemeClr val="lt1"/>
+          </a:fontRef>
+        </p:style>
+        <p:txBody>
+          <a:bodyPr rtlCol="0" anchor="ctr"/>
+          <a:lstStyle/>
+          <a:p>
+            <a:pPr algn="ctr">
+              <a:defRPr sz="1000">
+                <a:solidFill>
+                  <a:srgbClr val="718096"/>
+                </a:solidFill>
+                <a:latin typeface="Segoe UI"/>
+              </a:defRPr>
+            </a:pPr>
+            <a:r>
+              <a:t>[CHÚ THÍCH ẢNH CHỤP THỰC TẾ]</a:t>
             </a:r>
             <a:br/>
-          </a:p>
-          <a:p>
-            <a:pPr>
-              <a:defRPr sz="1050">
-                <a:solidFill>
-                  <a:srgbClr val="2D3748"/>
-                </a:solidFill>
-                <a:latin typeface="Segoe UI"/>
-              </a:defRPr>
-            </a:pPr>
-            <a:r>
-              <a:t>• Kiểm soát phiên bản: Sử dụng Git với quy chuẩn cam kết rõ ràng, quản lý các tệp migration theo thứ tự thời gian.</a:t>
-            </a:r>
             <a:br/>
-          </a:p>
-          <a:p>
-            <a:pPr>
-              <a:defRPr sz="1050">
-                <a:solidFill>
-                  <a:srgbClr val="2D3748"/>
-                </a:solidFill>
-                <a:latin typeface="Segoe UI"/>
-              </a:defRPr>
-            </a:pPr>
-            <a:r>
-              <a:t>• Quy trình kiểm soát chất lượng: Chạy kiểm thử hồi quy trước mỗi bản cập nhật lớn.</a:t>
+            <a:r>
+              <a:t>Hộp thoại lập hóa đơn hàng loạt tự động tính phí gửi xe máy, ô tô theo từng căn hộ.</a:t>
             </a:r>
             <a:br/>
-          </a:p>
-          <a:p>
-            <a:pPr>
-              <a:defRPr sz="1050">
-                <a:solidFill>
-                  <a:srgbClr val="2D3748"/>
-                </a:solidFill>
-                <a:latin typeface="Segoe UI"/>
-              </a:defRPr>
-            </a:pPr>
-            <a:r>
-              <a:t>• Tách biệt môi trường: Cấu hình khóa bí mật tách khỏi mã nguồn ứng dụng di động.</a:t>
-            </a:r>
             <a:br/>
+            <a:r>
+              <a:t>(Dán ảnh chụp màn hình điện thoại vào đây)</a:t>
+            </a:r>
+          </a:p>
+        </p:txBody>
+      </p:sp>
+      <p:sp>
+        <p:nvSpPr>
+          <p:cNvPr id="12" name="Rounded Rectangle 11"/>
+          <p:cNvSpPr/>
+          <p:nvPr/>
+        </p:nvSpPr>
+        <p:spPr>
+          <a:xfrm>
+            <a:off x="8046720" y="1371600"/>
+            <a:ext cx="3383280" cy="4937760"/>
+          </a:xfrm>
+          <a:prstGeom prst="roundRect">
+            <a:avLst/>
+          </a:prstGeom>
+          <a:solidFill>
+            <a:srgbClr val="FFFFFF"/>
+          </a:solidFill>
+          <a:ln w="19050">
+            <a:solidFill>
+              <a:srgbClr val="1A365D"/>
+            </a:solidFill>
+          </a:ln>
+        </p:spPr>
+        <p:style>
+          <a:lnRef idx="1">
+            <a:schemeClr val="accent1"/>
+          </a:lnRef>
+          <a:fillRef idx="3">
+            <a:schemeClr val="accent1"/>
+          </a:fillRef>
+          <a:effectRef idx="2">
+            <a:schemeClr val="accent1"/>
+          </a:effectRef>
+          <a:fontRef idx="minor">
+            <a:schemeClr val="lt1"/>
+          </a:fontRef>
+        </p:style>
+        <p:txBody>
+          <a:bodyPr rtlCol="0" anchor="ctr"/>
+          <a:lstStyle/>
+          <a:p>
+            <a:pPr algn="ctr"/>
+          </a:p>
+        </p:txBody>
+      </p:sp>
+      <p:sp>
+        <p:nvSpPr>
+          <p:cNvPr id="13" name="TextBox 12"/>
+          <p:cNvSpPr txBox="1"/>
+          <p:nvPr/>
+        </p:nvSpPr>
+        <p:spPr>
+          <a:xfrm>
+            <a:off x="8183880" y="1481328"/>
+            <a:ext cx="3108960" cy="411480"/>
+          </a:xfrm>
+          <a:prstGeom prst="rect">
+            <a:avLst/>
+          </a:prstGeom>
+          <a:noFill/>
+        </p:spPr>
+        <p:txBody>
+          <a:bodyPr wrap="square">
+            <a:spAutoFit/>
+          </a:bodyPr>
+          <a:lstStyle/>
+          <a:p>
+            <a:pPr>
+              <a:defRPr sz="1300" b="1">
+                <a:solidFill>
+                  <a:srgbClr val="1A365D"/>
+                </a:solidFill>
+                <a:latin typeface="Segoe UI"/>
+              </a:defRPr>
+            </a:pPr>
+            <a:r>
+              <a:t>ĐIỀU PHỐI SỰ CỐ &amp; KPI KỸ THUẬT</a:t>
+            </a:r>
+          </a:p>
+        </p:txBody>
+      </p:sp>
+      <p:sp>
+        <p:nvSpPr>
+          <p:cNvPr id="14" name="Rectangle 13"/>
+          <p:cNvSpPr/>
+          <p:nvPr/>
+        </p:nvSpPr>
+        <p:spPr>
+          <a:xfrm>
+            <a:off x="8229600" y="2011680"/>
+            <a:ext cx="3017520" cy="3474720"/>
+          </a:xfrm>
+          <a:prstGeom prst="rect">
+            <a:avLst/>
+          </a:prstGeom>
+          <a:solidFill>
+            <a:srgbClr val="F1F5F9"/>
+          </a:solidFill>
+          <a:ln w="19050">
+            <a:solidFill>
+              <a:srgbClr val="1A365D"/>
+            </a:solidFill>
+            <a:prstDash val="sysDash"/>
+          </a:ln>
+        </p:spPr>
+        <p:style>
+          <a:lnRef idx="1">
+            <a:schemeClr val="accent1"/>
+          </a:lnRef>
+          <a:fillRef idx="3">
+            <a:schemeClr val="accent1"/>
+          </a:fillRef>
+          <a:effectRef idx="2">
+            <a:schemeClr val="accent1"/>
+          </a:effectRef>
+          <a:fontRef idx="minor">
+            <a:schemeClr val="lt1"/>
+          </a:fontRef>
+        </p:style>
+        <p:txBody>
+          <a:bodyPr rtlCol="0" anchor="ctr"/>
+          <a:lstStyle/>
+          <a:p>
+            <a:pPr algn="ctr">
+              <a:defRPr sz="1000">
+                <a:solidFill>
+                  <a:srgbClr val="718096"/>
+                </a:solidFill>
+                <a:latin typeface="Segoe UI"/>
+              </a:defRPr>
+            </a:pPr>
+            <a:r>
+              <a:t>[CHÚ THÍCH ẢNH CHỤP THỰC TẾ]</a:t>
+            </a:r>
+            <a:br/>
+            <a:br/>
+            <a:r>
+              <a:t>Màn hình trao đổi bình luận thời gian thực và biểu đồ KPI đánh giá kỹ thuật viên 1 - 5 sao.</a:t>
+            </a:r>
+            <a:br/>
+            <a:br/>
+            <a:r>
+              <a:t>(Dán ảnh chụp màn hình điện thoại vào đây)</a:t>
+            </a:r>
           </a:p>
         </p:txBody>
       </p:sp>
@@ -8851,7 +8922,7 @@
               </a:defRPr>
             </a:pPr>
             <a:r>
-              <a:t>KẾT LUẬN VÀ HƯỚNG PHÁT TRIỂN TƯƠNG LAI</a:t>
+              <a:t>KẾ HOẠCH VÀ TIẾN ĐỘ THỰC HIỆN (BIỂU ĐỒ GANTT)</a:t>
             </a:r>
           </a:p>
         </p:txBody>
@@ -8899,16 +8970,40 @@
           </a:p>
         </p:txBody>
       </p:sp>
-      <p:sp>
-        <p:nvSpPr>
-          <p:cNvPr id="6" name="Rounded Rectangle 5"/>
+      <p:pic>
+        <p:nvPicPr>
+          <p:cNvPr id="6" name="Picture 5" descr="hinh3_1_gantt_tien_do.png"/>
+          <p:cNvPicPr>
+            <a:picLocks noChangeAspect="1"/>
+          </p:cNvPicPr>
+          <p:nvPr/>
+        </p:nvPicPr>
+        <p:blipFill>
+          <a:blip r:embed="rId2"/>
+          <a:stretch>
+            <a:fillRect/>
+          </a:stretch>
+        </p:blipFill>
+        <p:spPr>
+          <a:xfrm>
+            <a:off x="731520" y="1371600"/>
+            <a:ext cx="6583680" cy="3119856"/>
+          </a:xfrm>
+          <a:prstGeom prst="rect">
+            <a:avLst/>
+          </a:prstGeom>
+        </p:spPr>
+      </p:pic>
+      <p:sp>
+        <p:nvSpPr>
+          <p:cNvPr id="7" name="Rounded Rectangle 6"/>
           <p:cNvSpPr/>
           <p:nvPr/>
         </p:nvSpPr>
         <p:spPr>
           <a:xfrm>
-            <a:off x="731520" y="1371600"/>
-            <a:ext cx="5120640" cy="4937760"/>
+            <a:off x="7589520" y="1371600"/>
+            <a:ext cx="3840480" cy="4937760"/>
           </a:xfrm>
           <a:prstGeom prst="roundRect">
             <a:avLst/>
@@ -8918,7 +9013,7 @@
           </a:solidFill>
           <a:ln w="19050">
             <a:solidFill>
-              <a:srgbClr val="38A169"/>
+              <a:srgbClr val="3182CE"/>
             </a:solidFill>
           </a:ln>
         </p:spPr>
@@ -8946,14 +9041,14 @@
       </p:sp>
       <p:sp>
         <p:nvSpPr>
-          <p:cNvPr id="7" name="TextBox 6"/>
+          <p:cNvPr id="8" name="TextBox 7"/>
           <p:cNvSpPr txBox="1"/>
           <p:nvPr/>
         </p:nvSpPr>
         <p:spPr>
           <a:xfrm>
-            <a:off x="868680" y="1481328"/>
-            <a:ext cx="4846320" cy="411480"/>
+            <a:off x="7726680" y="1481328"/>
+            <a:ext cx="3566160" cy="411480"/>
           </a:xfrm>
           <a:prstGeom prst="rect">
             <a:avLst/>
@@ -8975,21 +9070,21 @@
               </a:defRPr>
             </a:pPr>
             <a:r>
-              <a:t>KẾT QUẢ ĐẠT ĐƯỢC</a:t>
-            </a:r>
-          </a:p>
-        </p:txBody>
-      </p:sp>
-      <p:sp>
-        <p:nvSpPr>
-          <p:cNvPr id="8" name="TextBox 7"/>
+              <a:t>QUẢN LÝ DỰ ÁN</a:t>
+            </a:r>
+          </a:p>
+        </p:txBody>
+      </p:sp>
+      <p:sp>
+        <p:nvSpPr>
+          <p:cNvPr id="9" name="TextBox 8"/>
           <p:cNvSpPr txBox="1"/>
           <p:nvPr/>
         </p:nvSpPr>
         <p:spPr>
           <a:xfrm>
-            <a:off x="914400" y="2011680"/>
-            <a:ext cx="4754880" cy="4114800"/>
+            <a:off x="7772400" y="1920240"/>
+            <a:ext cx="3474720" cy="4114800"/>
           </a:xfrm>
           <a:prstGeom prst="rect">
             <a:avLst/>
@@ -9003,7 +9098,7 @@
           <a:lstStyle/>
           <a:p>
             <a:pPr>
-              <a:defRPr sz="1100">
+              <a:defRPr sz="1050">
                 <a:solidFill>
                   <a:srgbClr val="2D3748"/>
                 </a:solidFill>
@@ -9011,13 +9106,13 @@
               </a:defRPr>
             </a:pPr>
             <a:r>
-              <a:t>• Hoàn thành 100% các tính năng đề ra: 24 yêu cầu chức năng, 10 yêu cầu phi chức năng.</a:t>
+              <a:t>• Khung thời gian: 6 tuần thực hiện nghiêm túc từ khảo sát đến bàn giao.</a:t>
             </a:r>
             <a:br/>
           </a:p>
           <a:p>
             <a:pPr>
-              <a:defRPr sz="1100">
+              <a:defRPr sz="1050">
                 <a:solidFill>
                   <a:srgbClr val="2D3748"/>
                 </a:solidFill>
@@ -9025,13 +9120,13 @@
               </a:defRPr>
             </a:pPr>
             <a:r>
-              <a:t>• Hiện thực hóa giải pháp bảo vệ dữ liệu ba lớp chống leo thang đặc quyền và toàn vẹn tài chính tại cơ sở dữ liệu.</a:t>
+              <a:t>• Kiểm soát phiên bản: Sử dụng Git với quy chuẩn cam kết rõ ràng, quản lý các tệp migration theo thứ tự thời gian.</a:t>
             </a:r>
             <a:br/>
           </a:p>
           <a:p>
             <a:pPr>
-              <a:defRPr sz="1100">
+              <a:defRPr sz="1050">
                 <a:solidFill>
                   <a:srgbClr val="2D3748"/>
                 </a:solidFill>
@@ -9039,13 +9134,13 @@
               </a:defRPr>
             </a:pPr>
             <a:r>
-              <a:t>• Hệ thống đạt chất lượng cao: 131 tệp kiểm thử với 395 ca test vượt qua tuyệt đối (100%).</a:t>
+              <a:t>• Quy trình kiểm soát chất lượng: Chạy kiểm thử hồi quy trước mỗi bản cập nhật lớn.</a:t>
             </a:r>
             <a:br/>
           </a:p>
           <a:p>
             <a:pPr>
-              <a:defRPr sz="1100">
+              <a:defRPr sz="1050">
                 <a:solidFill>
                   <a:srgbClr val="2D3748"/>
                 </a:solidFill>
@@ -9053,153 +9148,7 @@
               </a:defRPr>
             </a:pPr>
             <a:r>
-              <a:t>• Giao diện thân thiện, 100% tiếng Việt chuẩn mực, hỗ trợ co giãn linh hoạt trên mọi kích thước màn hình.</a:t>
-            </a:r>
-            <a:br/>
-          </a:p>
-        </p:txBody>
-      </p:sp>
-      <p:sp>
-        <p:nvSpPr>
-          <p:cNvPr id="9" name="Rounded Rectangle 8"/>
-          <p:cNvSpPr/>
-          <p:nvPr/>
-        </p:nvSpPr>
-        <p:spPr>
-          <a:xfrm>
-            <a:off x="6217920" y="1371600"/>
-            <a:ext cx="5212080" cy="4937760"/>
-          </a:xfrm>
-          <a:prstGeom prst="roundRect">
-            <a:avLst/>
-          </a:prstGeom>
-          <a:solidFill>
-            <a:srgbClr val="FFFFFF"/>
-          </a:solidFill>
-          <a:ln w="19050">
-            <a:solidFill>
-              <a:srgbClr val="DD6B20"/>
-            </a:solidFill>
-          </a:ln>
-        </p:spPr>
-        <p:style>
-          <a:lnRef idx="1">
-            <a:schemeClr val="accent1"/>
-          </a:lnRef>
-          <a:fillRef idx="3">
-            <a:schemeClr val="accent1"/>
-          </a:fillRef>
-          <a:effectRef idx="2">
-            <a:schemeClr val="accent1"/>
-          </a:effectRef>
-          <a:fontRef idx="minor">
-            <a:schemeClr val="lt1"/>
-          </a:fontRef>
-        </p:style>
-        <p:txBody>
-          <a:bodyPr rtlCol="0" anchor="ctr"/>
-          <a:lstStyle/>
-          <a:p>
-            <a:pPr algn="ctr"/>
-          </a:p>
-        </p:txBody>
-      </p:sp>
-      <p:sp>
-        <p:nvSpPr>
-          <p:cNvPr id="10" name="TextBox 9"/>
-          <p:cNvSpPr txBox="1"/>
-          <p:nvPr/>
-        </p:nvSpPr>
-        <p:spPr>
-          <a:xfrm>
-            <a:off x="6355080" y="1481328"/>
-            <a:ext cx="4937760" cy="411480"/>
-          </a:xfrm>
-          <a:prstGeom prst="rect">
-            <a:avLst/>
-          </a:prstGeom>
-          <a:noFill/>
-        </p:spPr>
-        <p:txBody>
-          <a:bodyPr wrap="square">
-            <a:spAutoFit/>
-          </a:bodyPr>
-          <a:lstStyle/>
-          <a:p>
-            <a:pPr>
-              <a:defRPr sz="1300" b="1">
-                <a:solidFill>
-                  <a:srgbClr val="1A365D"/>
-                </a:solidFill>
-                <a:latin typeface="Segoe UI"/>
-              </a:defRPr>
-            </a:pPr>
-            <a:r>
-              <a:t>HƯỚNG PHÁT TRIỂN</a:t>
-            </a:r>
-          </a:p>
-        </p:txBody>
-      </p:sp>
-      <p:sp>
-        <p:nvSpPr>
-          <p:cNvPr id="11" name="TextBox 10"/>
-          <p:cNvSpPr txBox="1"/>
-          <p:nvPr/>
-        </p:nvSpPr>
-        <p:spPr>
-          <a:xfrm>
-            <a:off x="6400800" y="2011680"/>
-            <a:ext cx="4846320" cy="4114800"/>
-          </a:xfrm>
-          <a:prstGeom prst="rect">
-            <a:avLst/>
-          </a:prstGeom>
-          <a:noFill/>
-        </p:spPr>
-        <p:txBody>
-          <a:bodyPr wrap="square">
-            <a:spAutoFit/>
-          </a:bodyPr>
-          <a:lstStyle/>
-          <a:p>
-            <a:pPr>
-              <a:defRPr sz="1100">
-                <a:solidFill>
-                  <a:srgbClr val="2D3748"/>
-                </a:solidFill>
-                <a:latin typeface="Segoe UI"/>
-              </a:defRPr>
-            </a:pPr>
-            <a:r>
-              <a:t>• Tích hợp Open Banking thực tế: Kết nối API ngân hàng thương mại để tự động gạch nợ hóa đơn thời gian thực.</a:t>
-            </a:r>
-            <a:br/>
-          </a:p>
-          <a:p>
-            <a:pPr>
-              <a:defRPr sz="1100">
-                <a:solidFill>
-                  <a:srgbClr val="2D3748"/>
-                </a:solidFill>
-                <a:latin typeface="Segoe UI"/>
-              </a:defRPr>
-            </a:pPr>
-            <a:r>
-              <a:t>• Ứng dụng thị giác máy tính AI: Huấn luyện mô hình cục bộ trên thiết bị di động hỗ trợ tự động nhận diện chỉ số công tơ điện nước và biển số xe tại sảnh.</a:t>
-            </a:r>
-            <a:br/>
-          </a:p>
-          <a:p>
-            <a:pPr>
-              <a:defRPr sz="1100">
-                <a:solidFill>
-                  <a:srgbClr val="2D3748"/>
-                </a:solidFill>
-                <a:latin typeface="Segoe UI"/>
-              </a:defRPr>
-            </a:pPr>
-            <a:r>
-              <a:t>• Mở rộng đa nền tảng: Đóng gói và phát hành ứng dụng trên nền tảng iOS và phiên bản web dành cho ban quản trị tòa nhà.</a:t>
+              <a:t>• Tách biệt môi trường: Cấu hình khóa bí mật tách khỏi mã nguồn ứng dụng di động.</a:t>
             </a:r>
             <a:br/>
           </a:p>
@@ -9232,7 +9181,7 @@
         <p:spPr>
           <a:xfrm>
             <a:off x="0" y="0"/>
-            <a:ext cx="12191695" cy="6858000"/>
+            <a:ext cx="12191695" cy="1051560"/>
           </a:xfrm>
           <a:prstGeom prst="rect">
             <a:avLst/>
@@ -9266,40 +9215,16 @@
           </a:p>
         </p:txBody>
       </p:sp>
-      <p:pic>
-        <p:nvPicPr>
-          <p:cNvPr id="3" name="Picture 2" descr="image1.png"/>
-          <p:cNvPicPr>
-            <a:picLocks noChangeAspect="1"/>
-          </p:cNvPicPr>
-          <p:nvPr/>
-        </p:nvPicPr>
-        <p:blipFill>
-          <a:blip r:embed="rId2"/>
-          <a:stretch>
-            <a:fillRect/>
-          </a:stretch>
-        </p:blipFill>
-        <p:spPr>
-          <a:xfrm>
-            <a:off x="5166360" y="1097280"/>
-            <a:ext cx="1997702" cy="1828800"/>
-          </a:xfrm>
-          <a:prstGeom prst="rect">
-            <a:avLst/>
-          </a:prstGeom>
-        </p:spPr>
-      </p:pic>
-      <p:sp>
-        <p:nvSpPr>
-          <p:cNvPr id="4" name="TextBox 3"/>
+      <p:sp>
+        <p:nvSpPr>
+          <p:cNvPr id="3" name="TextBox 2"/>
           <p:cNvSpPr txBox="1"/>
           <p:nvPr/>
         </p:nvSpPr>
         <p:spPr>
           <a:xfrm>
-            <a:off x="1371600" y="3108960"/>
-            <a:ext cx="9448495" cy="3200400"/>
+            <a:off x="731520" y="109728"/>
+            <a:ext cx="9144000" cy="274320"/>
           </a:xfrm>
           <a:prstGeom prst="rect">
             <a:avLst/>
@@ -9312,49 +9237,402 @@
           </a:bodyPr>
           <a:lstStyle/>
           <a:p>
-            <a:pPr algn="ctr">
-              <a:defRPr sz="2600" b="1">
-                <a:solidFill>
-                  <a:srgbClr val="DD6B20"/>
-                </a:solidFill>
-                <a:latin typeface="Segoe UI"/>
-              </a:defRPr>
-            </a:pPr>
-            <a:r>
-              <a:t>XIN CHÂN THÀNH CẢM ƠN QUÝ THẦY CÔ VÀ HỘI ĐỒNG ĐÁNH GIÁ!</a:t>
-            </a:r>
-          </a:p>
-          <a:p>
-            <a:pPr algn="ctr">
-              <a:defRPr sz="2000" b="1">
+            <a:pPr>
+              <a:defRPr sz="950" b="1">
+                <a:solidFill>
+                  <a:srgbClr val="3182CE"/>
+                </a:solidFill>
+                <a:latin typeface="Segoe UI"/>
+              </a:defRPr>
+            </a:pPr>
+            <a:r>
+              <a:t>ĐỒ ÁN LIÊN NGÀNH - TRƯỜNG CÔNG NGHỆ THÔNG TIN</a:t>
+            </a:r>
+          </a:p>
+        </p:txBody>
+      </p:sp>
+      <p:sp>
+        <p:nvSpPr>
+          <p:cNvPr id="4" name="TextBox 3"/>
+          <p:cNvSpPr txBox="1"/>
+          <p:nvPr/>
+        </p:nvSpPr>
+        <p:spPr>
+          <a:xfrm>
+            <a:off x="731520" y="384048"/>
+            <a:ext cx="10515600" cy="594360"/>
+          </a:xfrm>
+          <a:prstGeom prst="rect">
+            <a:avLst/>
+          </a:prstGeom>
+          <a:noFill/>
+        </p:spPr>
+        <p:txBody>
+          <a:bodyPr wrap="square">
+            <a:spAutoFit/>
+          </a:bodyPr>
+          <a:lstStyle/>
+          <a:p>
+            <a:pPr>
+              <a:defRPr sz="2200" b="1">
                 <a:solidFill>
                   <a:srgbClr val="FFFFFF"/>
                 </a:solidFill>
                 <a:latin typeface="Segoe UI"/>
               </a:defRPr>
             </a:pPr>
+            <a:r>
+              <a:t>KẾT LUẬN VÀ HƯỚNG PHÁT TRIỂN TƯƠNG LAI</a:t>
+            </a:r>
+          </a:p>
+        </p:txBody>
+      </p:sp>
+      <p:sp>
+        <p:nvSpPr>
+          <p:cNvPr id="5" name="Rectangle 4"/>
+          <p:cNvSpPr/>
+          <p:nvPr/>
+        </p:nvSpPr>
+        <p:spPr>
+          <a:xfrm>
+            <a:off x="0" y="1051560"/>
+            <a:ext cx="12191695" cy="45720"/>
+          </a:xfrm>
+          <a:prstGeom prst="rect">
+            <a:avLst/>
+          </a:prstGeom>
+          <a:solidFill>
+            <a:srgbClr val="DD6B20"/>
+          </a:solidFill>
+          <a:ln>
+            <a:noFill/>
+          </a:ln>
+        </p:spPr>
+        <p:style>
+          <a:lnRef idx="1">
+            <a:schemeClr val="accent1"/>
+          </a:lnRef>
+          <a:fillRef idx="3">
+            <a:schemeClr val="accent1"/>
+          </a:fillRef>
+          <a:effectRef idx="2">
+            <a:schemeClr val="accent1"/>
+          </a:effectRef>
+          <a:fontRef idx="minor">
+            <a:schemeClr val="lt1"/>
+          </a:fontRef>
+        </p:style>
+        <p:txBody>
+          <a:bodyPr rtlCol="0" anchor="ctr"/>
+          <a:lstStyle/>
+          <a:p>
+            <a:pPr algn="ctr"/>
+          </a:p>
+        </p:txBody>
+      </p:sp>
+      <p:sp>
+        <p:nvSpPr>
+          <p:cNvPr id="6" name="Rounded Rectangle 5"/>
+          <p:cNvSpPr/>
+          <p:nvPr/>
+        </p:nvSpPr>
+        <p:spPr>
+          <a:xfrm>
+            <a:off x="731520" y="1371600"/>
+            <a:ext cx="5120640" cy="4937760"/>
+          </a:xfrm>
+          <a:prstGeom prst="roundRect">
+            <a:avLst/>
+          </a:prstGeom>
+          <a:solidFill>
+            <a:srgbClr val="FFFFFF"/>
+          </a:solidFill>
+          <a:ln w="19050">
+            <a:solidFill>
+              <a:srgbClr val="38A169"/>
+            </a:solidFill>
+          </a:ln>
+        </p:spPr>
+        <p:style>
+          <a:lnRef idx="1">
+            <a:schemeClr val="accent1"/>
+          </a:lnRef>
+          <a:fillRef idx="3">
+            <a:schemeClr val="accent1"/>
+          </a:fillRef>
+          <a:effectRef idx="2">
+            <a:schemeClr val="accent1"/>
+          </a:effectRef>
+          <a:fontRef idx="minor">
+            <a:schemeClr val="lt1"/>
+          </a:fontRef>
+        </p:style>
+        <p:txBody>
+          <a:bodyPr rtlCol="0" anchor="ctr"/>
+          <a:lstStyle/>
+          <a:p>
+            <a:pPr algn="ctr"/>
+          </a:p>
+        </p:txBody>
+      </p:sp>
+      <p:sp>
+        <p:nvSpPr>
+          <p:cNvPr id="7" name="TextBox 6"/>
+          <p:cNvSpPr txBox="1"/>
+          <p:nvPr/>
+        </p:nvSpPr>
+        <p:spPr>
+          <a:xfrm>
+            <a:off x="868680" y="1481328"/>
+            <a:ext cx="4846320" cy="411480"/>
+          </a:xfrm>
+          <a:prstGeom prst="rect">
+            <a:avLst/>
+          </a:prstGeom>
+          <a:noFill/>
+        </p:spPr>
+        <p:txBody>
+          <a:bodyPr wrap="square">
+            <a:spAutoFit/>
+          </a:bodyPr>
+          <a:lstStyle/>
+          <a:p>
+            <a:pPr>
+              <a:defRPr sz="1300" b="1">
+                <a:solidFill>
+                  <a:srgbClr val="1A365D"/>
+                </a:solidFill>
+                <a:latin typeface="Segoe UI"/>
+              </a:defRPr>
+            </a:pPr>
+            <a:r>
+              <a:t>KẾT QUẢ ĐẠT ĐƯỢC</a:t>
+            </a:r>
+          </a:p>
+        </p:txBody>
+      </p:sp>
+      <p:sp>
+        <p:nvSpPr>
+          <p:cNvPr id="8" name="TextBox 7"/>
+          <p:cNvSpPr txBox="1"/>
+          <p:nvPr/>
+        </p:nvSpPr>
+        <p:spPr>
+          <a:xfrm>
+            <a:off x="914400" y="2011680"/>
+            <a:ext cx="4754880" cy="4114800"/>
+          </a:xfrm>
+          <a:prstGeom prst="rect">
+            <a:avLst/>
+          </a:prstGeom>
+          <a:noFill/>
+        </p:spPr>
+        <p:txBody>
+          <a:bodyPr wrap="square">
+            <a:spAutoFit/>
+          </a:bodyPr>
+          <a:lstStyle/>
+          <a:p>
+            <a:pPr>
+              <a:defRPr sz="1100">
+                <a:solidFill>
+                  <a:srgbClr val="2D3748"/>
+                </a:solidFill>
+                <a:latin typeface="Segoe UI"/>
+              </a:defRPr>
+            </a:pPr>
+            <a:r>
+              <a:t>• Hoàn thành 100% các tính năng đề ra: 25 yêu cầu chức năng, 10 yêu cầu phi chức năng.</a:t>
+            </a:r>
             <a:br/>
-            <a:r>
-              <a:t>PHẦN GIẢI ĐÁP CÂU HỎI &amp; ĐÓNG GÓP Ý KIẾN (Q&amp;A)</a:t>
+          </a:p>
+          <a:p>
+            <a:pPr>
+              <a:defRPr sz="1100">
+                <a:solidFill>
+                  <a:srgbClr val="2D3748"/>
+                </a:solidFill>
+                <a:latin typeface="Segoe UI"/>
+              </a:defRPr>
+            </a:pPr>
+            <a:r>
+              <a:t>• Hiện thực hóa giải pháp bảo vệ dữ liệu ba lớp chống leo thang đặc quyền và toàn vẹn tài chính tại cơ sở dữ liệu.</a:t>
             </a:r>
             <a:br/>
           </a:p>
           <a:p>
-            <a:pPr algn="ctr">
-              <a:defRPr sz="1300">
-                <a:solidFill>
-                  <a:srgbClr val="E2E8F0"/>
-                </a:solidFill>
-                <a:latin typeface="Segoe UI"/>
-              </a:defRPr>
-            </a:pPr>
-            <a:r>
-              <a:t>Sinh viên thực hiện: Phạm Văn Minh - Mã sinh viên: 23010350</a:t>
+            <a:pPr>
+              <a:defRPr sz="1100">
+                <a:solidFill>
+                  <a:srgbClr val="2D3748"/>
+                </a:solidFill>
+                <a:latin typeface="Segoe UI"/>
+              </a:defRPr>
+            </a:pPr>
+            <a:r>
+              <a:t>• Hệ thống đạt chất lượng cao: 131 tệp kiểm thử với 408 ca test (100% logic test vượt qua).</a:t>
             </a:r>
             <a:br/>
-            <a:r>
-              <a:t>Trường Đại học Phenikaa</a:t>
-            </a:r>
+          </a:p>
+          <a:p>
+            <a:pPr>
+              <a:defRPr sz="1100">
+                <a:solidFill>
+                  <a:srgbClr val="2D3748"/>
+                </a:solidFill>
+                <a:latin typeface="Segoe UI"/>
+              </a:defRPr>
+            </a:pPr>
+            <a:r>
+              <a:t>• Giao diện thân thiện, 100% tiếng Việt chuẩn mực, hỗ trợ co giãn linh hoạt trên mọi kích thước màn hình.</a:t>
+            </a:r>
+            <a:br/>
+          </a:p>
+        </p:txBody>
+      </p:sp>
+      <p:sp>
+        <p:nvSpPr>
+          <p:cNvPr id="9" name="Rounded Rectangle 8"/>
+          <p:cNvSpPr/>
+          <p:nvPr/>
+        </p:nvSpPr>
+        <p:spPr>
+          <a:xfrm>
+            <a:off x="6217920" y="1371600"/>
+            <a:ext cx="5212080" cy="4937760"/>
+          </a:xfrm>
+          <a:prstGeom prst="roundRect">
+            <a:avLst/>
+          </a:prstGeom>
+          <a:solidFill>
+            <a:srgbClr val="FFFFFF"/>
+          </a:solidFill>
+          <a:ln w="19050">
+            <a:solidFill>
+              <a:srgbClr val="DD6B20"/>
+            </a:solidFill>
+          </a:ln>
+        </p:spPr>
+        <p:style>
+          <a:lnRef idx="1">
+            <a:schemeClr val="accent1"/>
+          </a:lnRef>
+          <a:fillRef idx="3">
+            <a:schemeClr val="accent1"/>
+          </a:fillRef>
+          <a:effectRef idx="2">
+            <a:schemeClr val="accent1"/>
+          </a:effectRef>
+          <a:fontRef idx="minor">
+            <a:schemeClr val="lt1"/>
+          </a:fontRef>
+        </p:style>
+        <p:txBody>
+          <a:bodyPr rtlCol="0" anchor="ctr"/>
+          <a:lstStyle/>
+          <a:p>
+            <a:pPr algn="ctr"/>
+          </a:p>
+        </p:txBody>
+      </p:sp>
+      <p:sp>
+        <p:nvSpPr>
+          <p:cNvPr id="10" name="TextBox 9"/>
+          <p:cNvSpPr txBox="1"/>
+          <p:nvPr/>
+        </p:nvSpPr>
+        <p:spPr>
+          <a:xfrm>
+            <a:off x="6355080" y="1481328"/>
+            <a:ext cx="4937760" cy="411480"/>
+          </a:xfrm>
+          <a:prstGeom prst="rect">
+            <a:avLst/>
+          </a:prstGeom>
+          <a:noFill/>
+        </p:spPr>
+        <p:txBody>
+          <a:bodyPr wrap="square">
+            <a:spAutoFit/>
+          </a:bodyPr>
+          <a:lstStyle/>
+          <a:p>
+            <a:pPr>
+              <a:defRPr sz="1300" b="1">
+                <a:solidFill>
+                  <a:srgbClr val="1A365D"/>
+                </a:solidFill>
+                <a:latin typeface="Segoe UI"/>
+              </a:defRPr>
+            </a:pPr>
+            <a:r>
+              <a:t>HƯỚNG PHÁT TRIỂN</a:t>
+            </a:r>
+          </a:p>
+        </p:txBody>
+      </p:sp>
+      <p:sp>
+        <p:nvSpPr>
+          <p:cNvPr id="11" name="TextBox 10"/>
+          <p:cNvSpPr txBox="1"/>
+          <p:nvPr/>
+        </p:nvSpPr>
+        <p:spPr>
+          <a:xfrm>
+            <a:off x="6400800" y="2011680"/>
+            <a:ext cx="4846320" cy="4114800"/>
+          </a:xfrm>
+          <a:prstGeom prst="rect">
+            <a:avLst/>
+          </a:prstGeom>
+          <a:noFill/>
+        </p:spPr>
+        <p:txBody>
+          <a:bodyPr wrap="square">
+            <a:spAutoFit/>
+          </a:bodyPr>
+          <a:lstStyle/>
+          <a:p>
+            <a:pPr>
+              <a:defRPr sz="1100">
+                <a:solidFill>
+                  <a:srgbClr val="2D3748"/>
+                </a:solidFill>
+                <a:latin typeface="Segoe UI"/>
+              </a:defRPr>
+            </a:pPr>
+            <a:r>
+              <a:t>• Tích hợp Open Banking thực tế: Kết nối API ngân hàng thương mại để tự động gạch nợ hóa đơn thời gian thực.</a:t>
+            </a:r>
+            <a:br/>
+          </a:p>
+          <a:p>
+            <a:pPr>
+              <a:defRPr sz="1100">
+                <a:solidFill>
+                  <a:srgbClr val="2D3748"/>
+                </a:solidFill>
+                <a:latin typeface="Segoe UI"/>
+              </a:defRPr>
+            </a:pPr>
+            <a:r>
+              <a:t>• Ứng dụng thị giác máy tính AI: Huấn luyện mô hình cục bộ trên thiết bị di động hỗ trợ tự động nhận diện chỉ số công tơ điện nước và biển số xe tại sảnh.</a:t>
+            </a:r>
+            <a:br/>
+          </a:p>
+          <a:p>
+            <a:pPr>
+              <a:defRPr sz="1100">
+                <a:solidFill>
+                  <a:srgbClr val="2D3748"/>
+                </a:solidFill>
+                <a:latin typeface="Segoe UI"/>
+              </a:defRPr>
+            </a:pPr>
+            <a:r>
+              <a:t>• Mở rộng đa nền tảng: Đóng gói và phát hành ứng dụng trên nền tảng iOS và phiên bản web dành cho ban quản trị tòa nhà.</a:t>
+            </a:r>
+            <a:br/>
           </a:p>
         </p:txBody>
       </p:sp>
@@ -10718,6 +10996,159 @@
 </p:sld>
 </file>
 
+<file path=ppt/slides/slide20.xml><?xml version="1.0" encoding="utf-8"?>
+<p:sld xmlns:a="http://schemas.openxmlformats.org/drawingml/2006/main" xmlns:p="http://schemas.openxmlformats.org/presentationml/2006/main" xmlns:r="http://schemas.openxmlformats.org/officeDocument/2006/relationships">
+  <p:cSld>
+    <p:spTree>
+      <p:nvGrpSpPr>
+        <p:cNvPr id="1" name=""/>
+        <p:cNvGrpSpPr/>
+        <p:nvPr/>
+      </p:nvGrpSpPr>
+      <p:grpSpPr/>
+      <p:sp>
+        <p:nvSpPr>
+          <p:cNvPr id="2" name="Rectangle 1"/>
+          <p:cNvSpPr/>
+          <p:nvPr/>
+        </p:nvSpPr>
+        <p:spPr>
+          <a:xfrm>
+            <a:off x="0" y="0"/>
+            <a:ext cx="12191695" cy="6858000"/>
+          </a:xfrm>
+          <a:prstGeom prst="rect">
+            <a:avLst/>
+          </a:prstGeom>
+          <a:solidFill>
+            <a:srgbClr val="1A365D"/>
+          </a:solidFill>
+          <a:ln>
+            <a:noFill/>
+          </a:ln>
+        </p:spPr>
+        <p:style>
+          <a:lnRef idx="1">
+            <a:schemeClr val="accent1"/>
+          </a:lnRef>
+          <a:fillRef idx="3">
+            <a:schemeClr val="accent1"/>
+          </a:fillRef>
+          <a:effectRef idx="2">
+            <a:schemeClr val="accent1"/>
+          </a:effectRef>
+          <a:fontRef idx="minor">
+            <a:schemeClr val="lt1"/>
+          </a:fontRef>
+        </p:style>
+        <p:txBody>
+          <a:bodyPr rtlCol="0" anchor="ctr"/>
+          <a:lstStyle/>
+          <a:p>
+            <a:pPr algn="ctr"/>
+          </a:p>
+        </p:txBody>
+      </p:sp>
+      <p:pic>
+        <p:nvPicPr>
+          <p:cNvPr id="3" name="Picture 2" descr="image1.png"/>
+          <p:cNvPicPr>
+            <a:picLocks noChangeAspect="1"/>
+          </p:cNvPicPr>
+          <p:nvPr/>
+        </p:nvPicPr>
+        <p:blipFill>
+          <a:blip r:embed="rId2"/>
+          <a:stretch>
+            <a:fillRect/>
+          </a:stretch>
+        </p:blipFill>
+        <p:spPr>
+          <a:xfrm>
+            <a:off x="5166360" y="1097280"/>
+            <a:ext cx="1997702" cy="1828800"/>
+          </a:xfrm>
+          <a:prstGeom prst="rect">
+            <a:avLst/>
+          </a:prstGeom>
+        </p:spPr>
+      </p:pic>
+      <p:sp>
+        <p:nvSpPr>
+          <p:cNvPr id="4" name="TextBox 3"/>
+          <p:cNvSpPr txBox="1"/>
+          <p:nvPr/>
+        </p:nvSpPr>
+        <p:spPr>
+          <a:xfrm>
+            <a:off x="1371600" y="3108960"/>
+            <a:ext cx="9448495" cy="3200400"/>
+          </a:xfrm>
+          <a:prstGeom prst="rect">
+            <a:avLst/>
+          </a:prstGeom>
+          <a:noFill/>
+        </p:spPr>
+        <p:txBody>
+          <a:bodyPr wrap="square">
+            <a:spAutoFit/>
+          </a:bodyPr>
+          <a:lstStyle/>
+          <a:p>
+            <a:pPr algn="ctr">
+              <a:defRPr sz="2600" b="1">
+                <a:solidFill>
+                  <a:srgbClr val="DD6B20"/>
+                </a:solidFill>
+                <a:latin typeface="Segoe UI"/>
+              </a:defRPr>
+            </a:pPr>
+            <a:r>
+              <a:t>XIN CHÂN THÀNH CẢM ƠN QUÝ THẦY CÔ VÀ HỘI ĐỒNG ĐÁNH GIÁ!</a:t>
+            </a:r>
+          </a:p>
+          <a:p>
+            <a:pPr algn="ctr">
+              <a:defRPr sz="2000" b="1">
+                <a:solidFill>
+                  <a:srgbClr val="FFFFFF"/>
+                </a:solidFill>
+                <a:latin typeface="Segoe UI"/>
+              </a:defRPr>
+            </a:pPr>
+            <a:br/>
+            <a:r>
+              <a:t>PHẦN GIẢI ĐÁP CÂU HỎI &amp; ĐÓNG GÓP Ý KIẾN (Q&amp;A)</a:t>
+            </a:r>
+            <a:br/>
+          </a:p>
+          <a:p>
+            <a:pPr algn="ctr">
+              <a:defRPr sz="1300">
+                <a:solidFill>
+                  <a:srgbClr val="E2E8F0"/>
+                </a:solidFill>
+                <a:latin typeface="Segoe UI"/>
+              </a:defRPr>
+            </a:pPr>
+            <a:r>
+              <a:t>Sinh viên thực hiện: Phạm Văn Minh - Mã sinh viên: 23010350</a:t>
+            </a:r>
+            <a:br/>
+            <a:r>
+              <a:t>Trường Đại học Phenikaa</a:t>
+            </a:r>
+          </a:p>
+        </p:txBody>
+      </p:sp>
+    </p:spTree>
+  </p:cSld>
+  <p:clrMapOvr>
+    <a:masterClrMapping/>
+  </p:clrMapOvr>
+</p:sld>
+</file>
+
 <file path=ppt/slides/slide3.xml><?xml version="1.0" encoding="utf-8"?>
 <p:sld xmlns:a="http://schemas.openxmlformats.org/drawingml/2006/main" xmlns:p="http://schemas.openxmlformats.org/presentationml/2006/main" xmlns:r="http://schemas.openxmlformats.org/officeDocument/2006/relationships">
   <p:cSld>
@@ -13116,7 +13547,7 @@
         <p:spPr>
           <a:xfrm>
             <a:off x="731520" y="1371600"/>
-            <a:ext cx="5212080" cy="3207434"/>
+            <a:ext cx="5212080" cy="3263639"/>
           </a:xfrm>
           <a:prstGeom prst="rect">
             <a:avLst/>
@@ -13140,7 +13571,7 @@
         <p:spPr>
           <a:xfrm>
             <a:off x="6217920" y="1371600"/>
-            <a:ext cx="5212080" cy="3538476"/>
+            <a:ext cx="5212080" cy="3615587"/>
           </a:xfrm>
           <a:prstGeom prst="rect">
             <a:avLst/>

</xml_diff>